<commit_message>
Metafiles: PolyDraw, MaskBlt, PlgBlt, OffsetClipRgn; hatches as pixel tiles
EMF gains POLYDRAW/POLYDRAW16 (moves, lines, Béziers, closed figures, also
inside paths), MASKBLT and PLGBLT (masks read from their bits, as they come
without a color table; parallelograms as affine images) and OFFSETCLIPRGN
(also in WMF). Hatch brushes of GDI and GDI+ are 8 x 8 pixel tiles in output
pixels. The metafiles deck gets a slide of GDI records recorded through
gdi32 (98.3 %); the catalog marks picture.metafiles done.

Co-Authored-By: Claude Opus 5.5 <noreply@anthropic.com>
</commit_message>
<xml_diff>
--- a/tests/corpus/pptx/generated/metafiles.pptx
+++ b/tests/corpus/pptx/generated/metafiles.pptx
@@ -8,6 +8,7 @@
     <p:sldId id="256" r:id="rId2"/>
     <p:sldId id="257" r:id="rId3"/>
     <p:sldId id="258" r:id="rId4"/>
+    <p:sldId id="259" r:id="rId5"/>
   </p:sldIdLst>
   <p:sldSz cx="12192000" cy="6858000"/>
   <p:notesSz cx="6858000" cy="9144000"/>
@@ -131,7 +132,7 @@
           <p:cNvPr id="2" name="Titel 1">
             <a:extLst>
               <a:ext uri="{FF2B5EF4-FFF2-40B4-BE49-F238E27FC236}">
-                <a16:creationId xmlns:a16="http://schemas.microsoft.com/office/drawing/2014/main" id="{6E9BD11E-55B0-7F1E-9566-DFE2957DD313}"/>
+                <a16:creationId xmlns:a16="http://schemas.microsoft.com/office/drawing/2014/main" id="{80CA75CD-C2E6-EA03-F8D4-022D856D65FD}"/>
               </a:ext>
             </a:extLst>
           </p:cNvPr>
@@ -168,7 +169,7 @@
           <p:cNvPr id="3" name="Untertitel 2">
             <a:extLst>
               <a:ext uri="{FF2B5EF4-FFF2-40B4-BE49-F238E27FC236}">
-                <a16:creationId xmlns:a16="http://schemas.microsoft.com/office/drawing/2014/main" id="{9D5D00EA-B7E1-1670-7A8B-BB6FF16A8F6F}"/>
+                <a16:creationId xmlns:a16="http://schemas.microsoft.com/office/drawing/2014/main" id="{ED07CAB7-9CDF-34D8-D306-61BC10004FD3}"/>
               </a:ext>
             </a:extLst>
           </p:cNvPr>
@@ -238,7 +239,7 @@
           <p:cNvPr id="4" name="Datumsplatzhalter 3">
             <a:extLst>
               <a:ext uri="{FF2B5EF4-FFF2-40B4-BE49-F238E27FC236}">
-                <a16:creationId xmlns:a16="http://schemas.microsoft.com/office/drawing/2014/main" id="{BEB0C2A4-A4C5-686D-D813-267FF0C87BEF}"/>
+                <a16:creationId xmlns:a16="http://schemas.microsoft.com/office/drawing/2014/main" id="{096918C6-42B1-E70F-D6D5-EB6506AE1388}"/>
               </a:ext>
             </a:extLst>
           </p:cNvPr>
@@ -254,9 +255,9 @@
           <a:bodyPr/>
           <a:lstStyle/>
           <a:p>
-            <a:fld id="{0DF84070-F85C-4111-A372-7E705E3388D5}" type="datetimeFigureOut">
+            <a:fld id="{A8654E22-CD58-42EE-B3F1-F6E95B788638}" type="datetimeFigureOut">
               <a:rPr lang="de-DE" smtClean="0"/>
-              <a:t>08.10.2026</a:t>
+              <a:t>09.10.2026</a:t>
             </a:fld>
             <a:endParaRPr lang="de-DE"/>
           </a:p>
@@ -267,7 +268,7 @@
           <p:cNvPr id="5" name="Fußzeilenplatzhalter 4">
             <a:extLst>
               <a:ext uri="{FF2B5EF4-FFF2-40B4-BE49-F238E27FC236}">
-                <a16:creationId xmlns:a16="http://schemas.microsoft.com/office/drawing/2014/main" id="{81ABC6B1-D888-8771-EE21-73884707968B}"/>
+                <a16:creationId xmlns:a16="http://schemas.microsoft.com/office/drawing/2014/main" id="{B498DB3F-863F-86F0-1A58-ACD7377FBC55}"/>
               </a:ext>
             </a:extLst>
           </p:cNvPr>
@@ -292,7 +293,7 @@
           <p:cNvPr id="6" name="Foliennummernplatzhalter 5">
             <a:extLst>
               <a:ext uri="{FF2B5EF4-FFF2-40B4-BE49-F238E27FC236}">
-                <a16:creationId xmlns:a16="http://schemas.microsoft.com/office/drawing/2014/main" id="{D5BB1FFF-0C6C-0088-A440-12F68D387D2A}"/>
+                <a16:creationId xmlns:a16="http://schemas.microsoft.com/office/drawing/2014/main" id="{2D31AF2E-741E-3463-9921-F50C8A730357}"/>
               </a:ext>
             </a:extLst>
           </p:cNvPr>
@@ -308,7 +309,7 @@
           <a:bodyPr/>
           <a:lstStyle/>
           <a:p>
-            <a:fld id="{21AE39B9-E078-4A98-B70F-66F2A2822D52}" type="slidenum">
+            <a:fld id="{D2244B1B-211B-4F22-B4EF-514648639456}" type="slidenum">
               <a:rPr lang="de-DE" smtClean="0"/>
               <a:t>‹Nr.›</a:t>
             </a:fld>
@@ -319,7 +320,7 @@
     </p:spTree>
     <p:extLst>
       <p:ext uri="{BB962C8B-B14F-4D97-AF65-F5344CB8AC3E}">
-        <p14:creationId xmlns:p14="http://schemas.microsoft.com/office/powerpoint/2010/main" val="1471607063"/>
+        <p14:creationId xmlns:p14="http://schemas.microsoft.com/office/powerpoint/2010/main" val="2255203854"/>
       </p:ext>
     </p:extLst>
   </p:cSld>
@@ -351,7 +352,7 @@
           <p:cNvPr id="2" name="Titel 1">
             <a:extLst>
               <a:ext uri="{FF2B5EF4-FFF2-40B4-BE49-F238E27FC236}">
-                <a16:creationId xmlns:a16="http://schemas.microsoft.com/office/drawing/2014/main" id="{6EA417CC-526F-E1C2-EE0E-C43EE89A3370}"/>
+                <a16:creationId xmlns:a16="http://schemas.microsoft.com/office/drawing/2014/main" id="{A9CE5DB3-B17F-A29B-9A73-F7611361D449}"/>
               </a:ext>
             </a:extLst>
           </p:cNvPr>
@@ -379,7 +380,7 @@
           <p:cNvPr id="3" name="Vertikaler Textplatzhalter 2">
             <a:extLst>
               <a:ext uri="{FF2B5EF4-FFF2-40B4-BE49-F238E27FC236}">
-                <a16:creationId xmlns:a16="http://schemas.microsoft.com/office/drawing/2014/main" id="{21BB0F4C-DAE8-2031-90F0-587AB1CD0CF6}"/>
+                <a16:creationId xmlns:a16="http://schemas.microsoft.com/office/drawing/2014/main" id="{4C0113DD-5824-3C06-0C46-4582EA66AD1A}"/>
               </a:ext>
             </a:extLst>
           </p:cNvPr>
@@ -436,7 +437,7 @@
           <p:cNvPr id="4" name="Datumsplatzhalter 3">
             <a:extLst>
               <a:ext uri="{FF2B5EF4-FFF2-40B4-BE49-F238E27FC236}">
-                <a16:creationId xmlns:a16="http://schemas.microsoft.com/office/drawing/2014/main" id="{B4D72EAD-0FC4-7D55-E60A-4CD0178411C1}"/>
+                <a16:creationId xmlns:a16="http://schemas.microsoft.com/office/drawing/2014/main" id="{7F6CC2DC-D88C-BB63-80BE-9E3F35E701B3}"/>
               </a:ext>
             </a:extLst>
           </p:cNvPr>
@@ -452,9 +453,9 @@
           <a:bodyPr/>
           <a:lstStyle/>
           <a:p>
-            <a:fld id="{0DF84070-F85C-4111-A372-7E705E3388D5}" type="datetimeFigureOut">
+            <a:fld id="{A8654E22-CD58-42EE-B3F1-F6E95B788638}" type="datetimeFigureOut">
               <a:rPr lang="de-DE" smtClean="0"/>
-              <a:t>08.10.2026</a:t>
+              <a:t>09.10.2026</a:t>
             </a:fld>
             <a:endParaRPr lang="de-DE"/>
           </a:p>
@@ -465,7 +466,7 @@
           <p:cNvPr id="5" name="Fußzeilenplatzhalter 4">
             <a:extLst>
               <a:ext uri="{FF2B5EF4-FFF2-40B4-BE49-F238E27FC236}">
-                <a16:creationId xmlns:a16="http://schemas.microsoft.com/office/drawing/2014/main" id="{46735B12-83F3-E856-1EA4-1563C271A1B9}"/>
+                <a16:creationId xmlns:a16="http://schemas.microsoft.com/office/drawing/2014/main" id="{1E6AEDE3-A8B5-876F-BF46-D7807ABEFE23}"/>
               </a:ext>
             </a:extLst>
           </p:cNvPr>
@@ -490,7 +491,7 @@
           <p:cNvPr id="6" name="Foliennummernplatzhalter 5">
             <a:extLst>
               <a:ext uri="{FF2B5EF4-FFF2-40B4-BE49-F238E27FC236}">
-                <a16:creationId xmlns:a16="http://schemas.microsoft.com/office/drawing/2014/main" id="{9CA43A07-06BB-39ED-539F-F6BB8EC2C7E3}"/>
+                <a16:creationId xmlns:a16="http://schemas.microsoft.com/office/drawing/2014/main" id="{F8A3F119-801B-584C-67BA-DC9772A4F627}"/>
               </a:ext>
             </a:extLst>
           </p:cNvPr>
@@ -506,7 +507,7 @@
           <a:bodyPr/>
           <a:lstStyle/>
           <a:p>
-            <a:fld id="{21AE39B9-E078-4A98-B70F-66F2A2822D52}" type="slidenum">
+            <a:fld id="{D2244B1B-211B-4F22-B4EF-514648639456}" type="slidenum">
               <a:rPr lang="de-DE" smtClean="0"/>
               <a:t>‹Nr.›</a:t>
             </a:fld>
@@ -517,7 +518,7 @@
     </p:spTree>
     <p:extLst>
       <p:ext uri="{BB962C8B-B14F-4D97-AF65-F5344CB8AC3E}">
-        <p14:creationId xmlns:p14="http://schemas.microsoft.com/office/powerpoint/2010/main" val="263162752"/>
+        <p14:creationId xmlns:p14="http://schemas.microsoft.com/office/powerpoint/2010/main" val="3755669437"/>
       </p:ext>
     </p:extLst>
   </p:cSld>
@@ -549,7 +550,7 @@
           <p:cNvPr id="2" name="Vertikaler Titel 1">
             <a:extLst>
               <a:ext uri="{FF2B5EF4-FFF2-40B4-BE49-F238E27FC236}">
-                <a16:creationId xmlns:a16="http://schemas.microsoft.com/office/drawing/2014/main" id="{F617A6E8-30BD-DAF4-3DE4-9BAA5EF706A5}"/>
+                <a16:creationId xmlns:a16="http://schemas.microsoft.com/office/drawing/2014/main" id="{E05BFC61-FCED-840F-E57E-0A4E540C9AEE}"/>
               </a:ext>
             </a:extLst>
           </p:cNvPr>
@@ -582,7 +583,7 @@
           <p:cNvPr id="3" name="Vertikaler Textplatzhalter 2">
             <a:extLst>
               <a:ext uri="{FF2B5EF4-FFF2-40B4-BE49-F238E27FC236}">
-                <a16:creationId xmlns:a16="http://schemas.microsoft.com/office/drawing/2014/main" id="{7A07CD2D-1A8C-73D8-78A7-42267B7C167F}"/>
+                <a16:creationId xmlns:a16="http://schemas.microsoft.com/office/drawing/2014/main" id="{73EFD4C4-5D11-5F8F-4C88-2E89675F26FC}"/>
               </a:ext>
             </a:extLst>
           </p:cNvPr>
@@ -644,7 +645,7 @@
           <p:cNvPr id="4" name="Datumsplatzhalter 3">
             <a:extLst>
               <a:ext uri="{FF2B5EF4-FFF2-40B4-BE49-F238E27FC236}">
-                <a16:creationId xmlns:a16="http://schemas.microsoft.com/office/drawing/2014/main" id="{4371FF44-ED8E-EB4F-C5B0-2C173F7EC759}"/>
+                <a16:creationId xmlns:a16="http://schemas.microsoft.com/office/drawing/2014/main" id="{13D92CF4-B86F-D10F-B179-73F9F750C1A8}"/>
               </a:ext>
             </a:extLst>
           </p:cNvPr>
@@ -660,9 +661,9 @@
           <a:bodyPr/>
           <a:lstStyle/>
           <a:p>
-            <a:fld id="{0DF84070-F85C-4111-A372-7E705E3388D5}" type="datetimeFigureOut">
+            <a:fld id="{A8654E22-CD58-42EE-B3F1-F6E95B788638}" type="datetimeFigureOut">
               <a:rPr lang="de-DE" smtClean="0"/>
-              <a:t>08.10.2026</a:t>
+              <a:t>09.10.2026</a:t>
             </a:fld>
             <a:endParaRPr lang="de-DE"/>
           </a:p>
@@ -673,7 +674,7 @@
           <p:cNvPr id="5" name="Fußzeilenplatzhalter 4">
             <a:extLst>
               <a:ext uri="{FF2B5EF4-FFF2-40B4-BE49-F238E27FC236}">
-                <a16:creationId xmlns:a16="http://schemas.microsoft.com/office/drawing/2014/main" id="{3763CAC6-A80B-C2E7-F204-D68F8E705B81}"/>
+                <a16:creationId xmlns:a16="http://schemas.microsoft.com/office/drawing/2014/main" id="{29FB9D42-4558-1481-7A60-9B87D1A64F62}"/>
               </a:ext>
             </a:extLst>
           </p:cNvPr>
@@ -698,7 +699,7 @@
           <p:cNvPr id="6" name="Foliennummernplatzhalter 5">
             <a:extLst>
               <a:ext uri="{FF2B5EF4-FFF2-40B4-BE49-F238E27FC236}">
-                <a16:creationId xmlns:a16="http://schemas.microsoft.com/office/drawing/2014/main" id="{A89D251A-DADF-FEFF-16DF-CE6B33554790}"/>
+                <a16:creationId xmlns:a16="http://schemas.microsoft.com/office/drawing/2014/main" id="{D4D0827F-4590-E436-B0A2-C95BAF370DF2}"/>
               </a:ext>
             </a:extLst>
           </p:cNvPr>
@@ -714,7 +715,7 @@
           <a:bodyPr/>
           <a:lstStyle/>
           <a:p>
-            <a:fld id="{21AE39B9-E078-4A98-B70F-66F2A2822D52}" type="slidenum">
+            <a:fld id="{D2244B1B-211B-4F22-B4EF-514648639456}" type="slidenum">
               <a:rPr lang="de-DE" smtClean="0"/>
               <a:t>‹Nr.›</a:t>
             </a:fld>
@@ -725,7 +726,7 @@
     </p:spTree>
     <p:extLst>
       <p:ext uri="{BB962C8B-B14F-4D97-AF65-F5344CB8AC3E}">
-        <p14:creationId xmlns:p14="http://schemas.microsoft.com/office/powerpoint/2010/main" val="4063496864"/>
+        <p14:creationId xmlns:p14="http://schemas.microsoft.com/office/powerpoint/2010/main" val="957403411"/>
       </p:ext>
     </p:extLst>
   </p:cSld>
@@ -757,7 +758,7 @@
           <p:cNvPr id="2" name="Titel 1">
             <a:extLst>
               <a:ext uri="{FF2B5EF4-FFF2-40B4-BE49-F238E27FC236}">
-                <a16:creationId xmlns:a16="http://schemas.microsoft.com/office/drawing/2014/main" id="{4E19F477-D8F8-6D86-3CBC-0A8E49DED673}"/>
+                <a16:creationId xmlns:a16="http://schemas.microsoft.com/office/drawing/2014/main" id="{9DB1B4ED-04AF-4FE9-81CB-9E70F8FD8003}"/>
               </a:ext>
             </a:extLst>
           </p:cNvPr>
@@ -785,7 +786,7 @@
           <p:cNvPr id="3" name="Inhaltsplatzhalter 2">
             <a:extLst>
               <a:ext uri="{FF2B5EF4-FFF2-40B4-BE49-F238E27FC236}">
-                <a16:creationId xmlns:a16="http://schemas.microsoft.com/office/drawing/2014/main" id="{D90013BC-D42A-2FB8-849B-3E73A7A1458C}"/>
+                <a16:creationId xmlns:a16="http://schemas.microsoft.com/office/drawing/2014/main" id="{B07D3BCF-8408-9A68-1C6F-12FDD0B0752A}"/>
               </a:ext>
             </a:extLst>
           </p:cNvPr>
@@ -842,7 +843,7 @@
           <p:cNvPr id="4" name="Datumsplatzhalter 3">
             <a:extLst>
               <a:ext uri="{FF2B5EF4-FFF2-40B4-BE49-F238E27FC236}">
-                <a16:creationId xmlns:a16="http://schemas.microsoft.com/office/drawing/2014/main" id="{E0BC0635-D029-DE52-D7FA-088DDD245F21}"/>
+                <a16:creationId xmlns:a16="http://schemas.microsoft.com/office/drawing/2014/main" id="{CCCE108E-2FB4-D4B8-6AC6-B13642BB6939}"/>
               </a:ext>
             </a:extLst>
           </p:cNvPr>
@@ -858,9 +859,9 @@
           <a:bodyPr/>
           <a:lstStyle/>
           <a:p>
-            <a:fld id="{0DF84070-F85C-4111-A372-7E705E3388D5}" type="datetimeFigureOut">
+            <a:fld id="{A8654E22-CD58-42EE-B3F1-F6E95B788638}" type="datetimeFigureOut">
               <a:rPr lang="de-DE" smtClean="0"/>
-              <a:t>08.10.2026</a:t>
+              <a:t>09.10.2026</a:t>
             </a:fld>
             <a:endParaRPr lang="de-DE"/>
           </a:p>
@@ -871,7 +872,7 @@
           <p:cNvPr id="5" name="Fußzeilenplatzhalter 4">
             <a:extLst>
               <a:ext uri="{FF2B5EF4-FFF2-40B4-BE49-F238E27FC236}">
-                <a16:creationId xmlns:a16="http://schemas.microsoft.com/office/drawing/2014/main" id="{85571775-CF75-0810-654E-F7A9F76C7A63}"/>
+                <a16:creationId xmlns:a16="http://schemas.microsoft.com/office/drawing/2014/main" id="{FB23FED4-5846-755D-55BD-39A97DBEC234}"/>
               </a:ext>
             </a:extLst>
           </p:cNvPr>
@@ -896,7 +897,7 @@
           <p:cNvPr id="6" name="Foliennummernplatzhalter 5">
             <a:extLst>
               <a:ext uri="{FF2B5EF4-FFF2-40B4-BE49-F238E27FC236}">
-                <a16:creationId xmlns:a16="http://schemas.microsoft.com/office/drawing/2014/main" id="{6F37B7A2-7083-11BD-68D3-8E22B2B17EB1}"/>
+                <a16:creationId xmlns:a16="http://schemas.microsoft.com/office/drawing/2014/main" id="{B7549C2E-1355-1D5F-35B3-82934E5BE17C}"/>
               </a:ext>
             </a:extLst>
           </p:cNvPr>
@@ -912,7 +913,7 @@
           <a:bodyPr/>
           <a:lstStyle/>
           <a:p>
-            <a:fld id="{21AE39B9-E078-4A98-B70F-66F2A2822D52}" type="slidenum">
+            <a:fld id="{D2244B1B-211B-4F22-B4EF-514648639456}" type="slidenum">
               <a:rPr lang="de-DE" smtClean="0"/>
               <a:t>‹Nr.›</a:t>
             </a:fld>
@@ -923,7 +924,7 @@
     </p:spTree>
     <p:extLst>
       <p:ext uri="{BB962C8B-B14F-4D97-AF65-F5344CB8AC3E}">
-        <p14:creationId xmlns:p14="http://schemas.microsoft.com/office/powerpoint/2010/main" val="2923250336"/>
+        <p14:creationId xmlns:p14="http://schemas.microsoft.com/office/powerpoint/2010/main" val="2011087560"/>
       </p:ext>
     </p:extLst>
   </p:cSld>
@@ -955,7 +956,7 @@
           <p:cNvPr id="2" name="Titel 1">
             <a:extLst>
               <a:ext uri="{FF2B5EF4-FFF2-40B4-BE49-F238E27FC236}">
-                <a16:creationId xmlns:a16="http://schemas.microsoft.com/office/drawing/2014/main" id="{C42AAE0E-13F8-D0E2-C34C-3EC6AFA645ED}"/>
+                <a16:creationId xmlns:a16="http://schemas.microsoft.com/office/drawing/2014/main" id="{9E4D754A-014C-A2E1-103E-E245CB535179}"/>
               </a:ext>
             </a:extLst>
           </p:cNvPr>
@@ -992,7 +993,7 @@
           <p:cNvPr id="3" name="Textplatzhalter 2">
             <a:extLst>
               <a:ext uri="{FF2B5EF4-FFF2-40B4-BE49-F238E27FC236}">
-                <a16:creationId xmlns:a16="http://schemas.microsoft.com/office/drawing/2014/main" id="{D1D68F3B-9915-D613-0236-2EFE7D98911E}"/>
+                <a16:creationId xmlns:a16="http://schemas.microsoft.com/office/drawing/2014/main" id="{FF0EBD0E-6829-F70A-BBA2-BABAD0C65854}"/>
               </a:ext>
             </a:extLst>
           </p:cNvPr>
@@ -1117,7 +1118,7 @@
           <p:cNvPr id="4" name="Datumsplatzhalter 3">
             <a:extLst>
               <a:ext uri="{FF2B5EF4-FFF2-40B4-BE49-F238E27FC236}">
-                <a16:creationId xmlns:a16="http://schemas.microsoft.com/office/drawing/2014/main" id="{48296700-F606-8C96-BF7F-B9D22A91639E}"/>
+                <a16:creationId xmlns:a16="http://schemas.microsoft.com/office/drawing/2014/main" id="{E442E34B-1A67-B092-0B6B-B8D4007EB342}"/>
               </a:ext>
             </a:extLst>
           </p:cNvPr>
@@ -1133,9 +1134,9 @@
           <a:bodyPr/>
           <a:lstStyle/>
           <a:p>
-            <a:fld id="{0DF84070-F85C-4111-A372-7E705E3388D5}" type="datetimeFigureOut">
+            <a:fld id="{A8654E22-CD58-42EE-B3F1-F6E95B788638}" type="datetimeFigureOut">
               <a:rPr lang="de-DE" smtClean="0"/>
-              <a:t>08.10.2026</a:t>
+              <a:t>09.10.2026</a:t>
             </a:fld>
             <a:endParaRPr lang="de-DE"/>
           </a:p>
@@ -1146,7 +1147,7 @@
           <p:cNvPr id="5" name="Fußzeilenplatzhalter 4">
             <a:extLst>
               <a:ext uri="{FF2B5EF4-FFF2-40B4-BE49-F238E27FC236}">
-                <a16:creationId xmlns:a16="http://schemas.microsoft.com/office/drawing/2014/main" id="{B7B1A590-865A-767C-D817-6F21BE07C134}"/>
+                <a16:creationId xmlns:a16="http://schemas.microsoft.com/office/drawing/2014/main" id="{BB9FE399-7B27-168B-C883-9B8F94E02E78}"/>
               </a:ext>
             </a:extLst>
           </p:cNvPr>
@@ -1171,7 +1172,7 @@
           <p:cNvPr id="6" name="Foliennummernplatzhalter 5">
             <a:extLst>
               <a:ext uri="{FF2B5EF4-FFF2-40B4-BE49-F238E27FC236}">
-                <a16:creationId xmlns:a16="http://schemas.microsoft.com/office/drawing/2014/main" id="{A1F2D9FF-6068-36DA-2529-C1E9B583DA2E}"/>
+                <a16:creationId xmlns:a16="http://schemas.microsoft.com/office/drawing/2014/main" id="{8EDF3608-2E17-CCC5-4607-2BFEFBECFD6F}"/>
               </a:ext>
             </a:extLst>
           </p:cNvPr>
@@ -1187,7 +1188,7 @@
           <a:bodyPr/>
           <a:lstStyle/>
           <a:p>
-            <a:fld id="{21AE39B9-E078-4A98-B70F-66F2A2822D52}" type="slidenum">
+            <a:fld id="{D2244B1B-211B-4F22-B4EF-514648639456}" type="slidenum">
               <a:rPr lang="de-DE" smtClean="0"/>
               <a:t>‹Nr.›</a:t>
             </a:fld>
@@ -1198,7 +1199,7 @@
     </p:spTree>
     <p:extLst>
       <p:ext uri="{BB962C8B-B14F-4D97-AF65-F5344CB8AC3E}">
-        <p14:creationId xmlns:p14="http://schemas.microsoft.com/office/powerpoint/2010/main" val="3628130797"/>
+        <p14:creationId xmlns:p14="http://schemas.microsoft.com/office/powerpoint/2010/main" val="4264342507"/>
       </p:ext>
     </p:extLst>
   </p:cSld>
@@ -1230,7 +1231,7 @@
           <p:cNvPr id="2" name="Titel 1">
             <a:extLst>
               <a:ext uri="{FF2B5EF4-FFF2-40B4-BE49-F238E27FC236}">
-                <a16:creationId xmlns:a16="http://schemas.microsoft.com/office/drawing/2014/main" id="{79DE37CD-2C69-B8FD-B1E8-01AA67565A45}"/>
+                <a16:creationId xmlns:a16="http://schemas.microsoft.com/office/drawing/2014/main" id="{E8631644-9F1B-01E6-4EFB-B0B9344DB448}"/>
               </a:ext>
             </a:extLst>
           </p:cNvPr>
@@ -1258,7 +1259,7 @@
           <p:cNvPr id="3" name="Inhaltsplatzhalter 2">
             <a:extLst>
               <a:ext uri="{FF2B5EF4-FFF2-40B4-BE49-F238E27FC236}">
-                <a16:creationId xmlns:a16="http://schemas.microsoft.com/office/drawing/2014/main" id="{4209B7BE-203B-1336-4EDD-7B84A52EDF37}"/>
+                <a16:creationId xmlns:a16="http://schemas.microsoft.com/office/drawing/2014/main" id="{647A5D2E-1562-2601-5333-951E5C321EA8}"/>
               </a:ext>
             </a:extLst>
           </p:cNvPr>
@@ -1320,7 +1321,7 @@
           <p:cNvPr id="4" name="Inhaltsplatzhalter 3">
             <a:extLst>
               <a:ext uri="{FF2B5EF4-FFF2-40B4-BE49-F238E27FC236}">
-                <a16:creationId xmlns:a16="http://schemas.microsoft.com/office/drawing/2014/main" id="{D8D86615-8395-4520-84D5-1802E56CA213}"/>
+                <a16:creationId xmlns:a16="http://schemas.microsoft.com/office/drawing/2014/main" id="{35FF889D-20AD-783B-39C7-F0E729114E85}"/>
               </a:ext>
             </a:extLst>
           </p:cNvPr>
@@ -1382,7 +1383,7 @@
           <p:cNvPr id="5" name="Datumsplatzhalter 4">
             <a:extLst>
               <a:ext uri="{FF2B5EF4-FFF2-40B4-BE49-F238E27FC236}">
-                <a16:creationId xmlns:a16="http://schemas.microsoft.com/office/drawing/2014/main" id="{C9D0AD64-57A1-EB22-78E7-F8DC9AE68972}"/>
+                <a16:creationId xmlns:a16="http://schemas.microsoft.com/office/drawing/2014/main" id="{8A4711B3-086A-E2EE-ECC6-5F05CB88991A}"/>
               </a:ext>
             </a:extLst>
           </p:cNvPr>
@@ -1398,9 +1399,9 @@
           <a:bodyPr/>
           <a:lstStyle/>
           <a:p>
-            <a:fld id="{0DF84070-F85C-4111-A372-7E705E3388D5}" type="datetimeFigureOut">
+            <a:fld id="{A8654E22-CD58-42EE-B3F1-F6E95B788638}" type="datetimeFigureOut">
               <a:rPr lang="de-DE" smtClean="0"/>
-              <a:t>08.10.2026</a:t>
+              <a:t>09.10.2026</a:t>
             </a:fld>
             <a:endParaRPr lang="de-DE"/>
           </a:p>
@@ -1411,7 +1412,7 @@
           <p:cNvPr id="6" name="Fußzeilenplatzhalter 5">
             <a:extLst>
               <a:ext uri="{FF2B5EF4-FFF2-40B4-BE49-F238E27FC236}">
-                <a16:creationId xmlns:a16="http://schemas.microsoft.com/office/drawing/2014/main" id="{77D95CD3-B9F2-72C2-E54E-180739EAF7C8}"/>
+                <a16:creationId xmlns:a16="http://schemas.microsoft.com/office/drawing/2014/main" id="{AB15B43A-EF6A-57B4-9C3F-2C0A40D89284}"/>
               </a:ext>
             </a:extLst>
           </p:cNvPr>
@@ -1436,7 +1437,7 @@
           <p:cNvPr id="7" name="Foliennummernplatzhalter 6">
             <a:extLst>
               <a:ext uri="{FF2B5EF4-FFF2-40B4-BE49-F238E27FC236}">
-                <a16:creationId xmlns:a16="http://schemas.microsoft.com/office/drawing/2014/main" id="{402B824D-55A8-7E8E-D3EC-BC5E1869BAC5}"/>
+                <a16:creationId xmlns:a16="http://schemas.microsoft.com/office/drawing/2014/main" id="{079E4A3C-52FF-8093-599F-590E946C7170}"/>
               </a:ext>
             </a:extLst>
           </p:cNvPr>
@@ -1452,7 +1453,7 @@
           <a:bodyPr/>
           <a:lstStyle/>
           <a:p>
-            <a:fld id="{21AE39B9-E078-4A98-B70F-66F2A2822D52}" type="slidenum">
+            <a:fld id="{D2244B1B-211B-4F22-B4EF-514648639456}" type="slidenum">
               <a:rPr lang="de-DE" smtClean="0"/>
               <a:t>‹Nr.›</a:t>
             </a:fld>
@@ -1463,7 +1464,7 @@
     </p:spTree>
     <p:extLst>
       <p:ext uri="{BB962C8B-B14F-4D97-AF65-F5344CB8AC3E}">
-        <p14:creationId xmlns:p14="http://schemas.microsoft.com/office/powerpoint/2010/main" val="2995776489"/>
+        <p14:creationId xmlns:p14="http://schemas.microsoft.com/office/powerpoint/2010/main" val="3116535132"/>
       </p:ext>
     </p:extLst>
   </p:cSld>
@@ -1495,7 +1496,7 @@
           <p:cNvPr id="2" name="Titel 1">
             <a:extLst>
               <a:ext uri="{FF2B5EF4-FFF2-40B4-BE49-F238E27FC236}">
-                <a16:creationId xmlns:a16="http://schemas.microsoft.com/office/drawing/2014/main" id="{5BE20460-A292-1310-444C-BD5C49E36286}"/>
+                <a16:creationId xmlns:a16="http://schemas.microsoft.com/office/drawing/2014/main" id="{4B6B0A6B-9AE8-4A9A-06DC-A01A006CFCBA}"/>
               </a:ext>
             </a:extLst>
           </p:cNvPr>
@@ -1528,7 +1529,7 @@
           <p:cNvPr id="3" name="Textplatzhalter 2">
             <a:extLst>
               <a:ext uri="{FF2B5EF4-FFF2-40B4-BE49-F238E27FC236}">
-                <a16:creationId xmlns:a16="http://schemas.microsoft.com/office/drawing/2014/main" id="{180DCE47-1BD2-C709-52D4-1B89F70954E8}"/>
+                <a16:creationId xmlns:a16="http://schemas.microsoft.com/office/drawing/2014/main" id="{48552E43-B4D2-3164-E66E-D1C7CD78EF07}"/>
               </a:ext>
             </a:extLst>
           </p:cNvPr>
@@ -1599,7 +1600,7 @@
           <p:cNvPr id="4" name="Inhaltsplatzhalter 3">
             <a:extLst>
               <a:ext uri="{FF2B5EF4-FFF2-40B4-BE49-F238E27FC236}">
-                <a16:creationId xmlns:a16="http://schemas.microsoft.com/office/drawing/2014/main" id="{5534621E-FC3A-F05F-4F61-F5C649FB299B}"/>
+                <a16:creationId xmlns:a16="http://schemas.microsoft.com/office/drawing/2014/main" id="{FCF17DED-B253-E4B3-8961-BA5194DDB72B}"/>
               </a:ext>
             </a:extLst>
           </p:cNvPr>
@@ -1661,7 +1662,7 @@
           <p:cNvPr id="5" name="Textplatzhalter 4">
             <a:extLst>
               <a:ext uri="{FF2B5EF4-FFF2-40B4-BE49-F238E27FC236}">
-                <a16:creationId xmlns:a16="http://schemas.microsoft.com/office/drawing/2014/main" id="{F12E34EA-641D-8D37-0E8D-AA9E55900938}"/>
+                <a16:creationId xmlns:a16="http://schemas.microsoft.com/office/drawing/2014/main" id="{65A44818-1A95-43FD-F4C4-3DB6BAD07005}"/>
               </a:ext>
             </a:extLst>
           </p:cNvPr>
@@ -1732,7 +1733,7 @@
           <p:cNvPr id="6" name="Inhaltsplatzhalter 5">
             <a:extLst>
               <a:ext uri="{FF2B5EF4-FFF2-40B4-BE49-F238E27FC236}">
-                <a16:creationId xmlns:a16="http://schemas.microsoft.com/office/drawing/2014/main" id="{ABB73B56-4564-150A-7C70-45012CC6929B}"/>
+                <a16:creationId xmlns:a16="http://schemas.microsoft.com/office/drawing/2014/main" id="{62E2A088-8230-1331-09EC-CBC828B36AA1}"/>
               </a:ext>
             </a:extLst>
           </p:cNvPr>
@@ -1794,7 +1795,7 @@
           <p:cNvPr id="7" name="Datumsplatzhalter 6">
             <a:extLst>
               <a:ext uri="{FF2B5EF4-FFF2-40B4-BE49-F238E27FC236}">
-                <a16:creationId xmlns:a16="http://schemas.microsoft.com/office/drawing/2014/main" id="{4A1F67C5-E9CE-D0FD-96F6-E11691B577ED}"/>
+                <a16:creationId xmlns:a16="http://schemas.microsoft.com/office/drawing/2014/main" id="{E69525BE-25BA-396E-6021-ABD71FEB91A4}"/>
               </a:ext>
             </a:extLst>
           </p:cNvPr>
@@ -1810,9 +1811,9 @@
           <a:bodyPr/>
           <a:lstStyle/>
           <a:p>
-            <a:fld id="{0DF84070-F85C-4111-A372-7E705E3388D5}" type="datetimeFigureOut">
+            <a:fld id="{A8654E22-CD58-42EE-B3F1-F6E95B788638}" type="datetimeFigureOut">
               <a:rPr lang="de-DE" smtClean="0"/>
-              <a:t>08.10.2026</a:t>
+              <a:t>09.10.2026</a:t>
             </a:fld>
             <a:endParaRPr lang="de-DE"/>
           </a:p>
@@ -1823,7 +1824,7 @@
           <p:cNvPr id="8" name="Fußzeilenplatzhalter 7">
             <a:extLst>
               <a:ext uri="{FF2B5EF4-FFF2-40B4-BE49-F238E27FC236}">
-                <a16:creationId xmlns:a16="http://schemas.microsoft.com/office/drawing/2014/main" id="{7466D55C-67E5-7D95-A162-D07ED1AE9265}"/>
+                <a16:creationId xmlns:a16="http://schemas.microsoft.com/office/drawing/2014/main" id="{E0A7848A-C879-1BC0-2468-A4C99346E234}"/>
               </a:ext>
             </a:extLst>
           </p:cNvPr>
@@ -1848,7 +1849,7 @@
           <p:cNvPr id="9" name="Foliennummernplatzhalter 8">
             <a:extLst>
               <a:ext uri="{FF2B5EF4-FFF2-40B4-BE49-F238E27FC236}">
-                <a16:creationId xmlns:a16="http://schemas.microsoft.com/office/drawing/2014/main" id="{ADEF3BF2-F33C-5CB5-7CBA-39C6649B0EC8}"/>
+                <a16:creationId xmlns:a16="http://schemas.microsoft.com/office/drawing/2014/main" id="{C8945D32-9FBA-9357-634B-4EFDDF9DD92A}"/>
               </a:ext>
             </a:extLst>
           </p:cNvPr>
@@ -1864,7 +1865,7 @@
           <a:bodyPr/>
           <a:lstStyle/>
           <a:p>
-            <a:fld id="{21AE39B9-E078-4A98-B70F-66F2A2822D52}" type="slidenum">
+            <a:fld id="{D2244B1B-211B-4F22-B4EF-514648639456}" type="slidenum">
               <a:rPr lang="de-DE" smtClean="0"/>
               <a:t>‹Nr.›</a:t>
             </a:fld>
@@ -1875,7 +1876,7 @@
     </p:spTree>
     <p:extLst>
       <p:ext uri="{BB962C8B-B14F-4D97-AF65-F5344CB8AC3E}">
-        <p14:creationId xmlns:p14="http://schemas.microsoft.com/office/powerpoint/2010/main" val="2541448205"/>
+        <p14:creationId xmlns:p14="http://schemas.microsoft.com/office/powerpoint/2010/main" val="3922570317"/>
       </p:ext>
     </p:extLst>
   </p:cSld>
@@ -1907,7 +1908,7 @@
           <p:cNvPr id="2" name="Titel 1">
             <a:extLst>
               <a:ext uri="{FF2B5EF4-FFF2-40B4-BE49-F238E27FC236}">
-                <a16:creationId xmlns:a16="http://schemas.microsoft.com/office/drawing/2014/main" id="{B102F476-6301-7F31-1B00-C97A0537E69A}"/>
+                <a16:creationId xmlns:a16="http://schemas.microsoft.com/office/drawing/2014/main" id="{5A38D023-4334-1B50-9719-4CCEDCA43CC1}"/>
               </a:ext>
             </a:extLst>
           </p:cNvPr>
@@ -1935,7 +1936,7 @@
           <p:cNvPr id="3" name="Datumsplatzhalter 2">
             <a:extLst>
               <a:ext uri="{FF2B5EF4-FFF2-40B4-BE49-F238E27FC236}">
-                <a16:creationId xmlns:a16="http://schemas.microsoft.com/office/drawing/2014/main" id="{29EDC889-C096-E7BC-72DA-EE9B50D1F879}"/>
+                <a16:creationId xmlns:a16="http://schemas.microsoft.com/office/drawing/2014/main" id="{8CFECB25-2E26-4CD1-8711-B9A1AFD9AC5C}"/>
               </a:ext>
             </a:extLst>
           </p:cNvPr>
@@ -1951,9 +1952,9 @@
           <a:bodyPr/>
           <a:lstStyle/>
           <a:p>
-            <a:fld id="{0DF84070-F85C-4111-A372-7E705E3388D5}" type="datetimeFigureOut">
+            <a:fld id="{A8654E22-CD58-42EE-B3F1-F6E95B788638}" type="datetimeFigureOut">
               <a:rPr lang="de-DE" smtClean="0"/>
-              <a:t>08.10.2026</a:t>
+              <a:t>09.10.2026</a:t>
             </a:fld>
             <a:endParaRPr lang="de-DE"/>
           </a:p>
@@ -1964,7 +1965,7 @@
           <p:cNvPr id="4" name="Fußzeilenplatzhalter 3">
             <a:extLst>
               <a:ext uri="{FF2B5EF4-FFF2-40B4-BE49-F238E27FC236}">
-                <a16:creationId xmlns:a16="http://schemas.microsoft.com/office/drawing/2014/main" id="{E7A06B62-892B-D379-4709-8109E428A5DA}"/>
+                <a16:creationId xmlns:a16="http://schemas.microsoft.com/office/drawing/2014/main" id="{FE24A258-8AC9-FDC7-1D57-6234EB51D649}"/>
               </a:ext>
             </a:extLst>
           </p:cNvPr>
@@ -1989,7 +1990,7 @@
           <p:cNvPr id="5" name="Foliennummernplatzhalter 4">
             <a:extLst>
               <a:ext uri="{FF2B5EF4-FFF2-40B4-BE49-F238E27FC236}">
-                <a16:creationId xmlns:a16="http://schemas.microsoft.com/office/drawing/2014/main" id="{89C76F0E-DE01-E438-42E1-2EA814818ED0}"/>
+                <a16:creationId xmlns:a16="http://schemas.microsoft.com/office/drawing/2014/main" id="{ABC9D2A1-8059-FCD2-F88D-BBE669C52C9F}"/>
               </a:ext>
             </a:extLst>
           </p:cNvPr>
@@ -2005,7 +2006,7 @@
           <a:bodyPr/>
           <a:lstStyle/>
           <a:p>
-            <a:fld id="{21AE39B9-E078-4A98-B70F-66F2A2822D52}" type="slidenum">
+            <a:fld id="{D2244B1B-211B-4F22-B4EF-514648639456}" type="slidenum">
               <a:rPr lang="de-DE" smtClean="0"/>
               <a:t>‹Nr.›</a:t>
             </a:fld>
@@ -2016,7 +2017,7 @@
     </p:spTree>
     <p:extLst>
       <p:ext uri="{BB962C8B-B14F-4D97-AF65-F5344CB8AC3E}">
-        <p14:creationId xmlns:p14="http://schemas.microsoft.com/office/powerpoint/2010/main" val="166044017"/>
+        <p14:creationId xmlns:p14="http://schemas.microsoft.com/office/powerpoint/2010/main" val="2045675039"/>
       </p:ext>
     </p:extLst>
   </p:cSld>
@@ -2048,7 +2049,7 @@
           <p:cNvPr id="2" name="Datumsplatzhalter 1">
             <a:extLst>
               <a:ext uri="{FF2B5EF4-FFF2-40B4-BE49-F238E27FC236}">
-                <a16:creationId xmlns:a16="http://schemas.microsoft.com/office/drawing/2014/main" id="{A2A26E8C-AC06-4732-989E-98AA8C7C9C13}"/>
+                <a16:creationId xmlns:a16="http://schemas.microsoft.com/office/drawing/2014/main" id="{4B0A6523-6169-6D5E-9573-6D6595DB214E}"/>
               </a:ext>
             </a:extLst>
           </p:cNvPr>
@@ -2064,9 +2065,9 @@
           <a:bodyPr/>
           <a:lstStyle/>
           <a:p>
-            <a:fld id="{0DF84070-F85C-4111-A372-7E705E3388D5}" type="datetimeFigureOut">
+            <a:fld id="{A8654E22-CD58-42EE-B3F1-F6E95B788638}" type="datetimeFigureOut">
               <a:rPr lang="de-DE" smtClean="0"/>
-              <a:t>08.10.2026</a:t>
+              <a:t>09.10.2026</a:t>
             </a:fld>
             <a:endParaRPr lang="de-DE"/>
           </a:p>
@@ -2077,7 +2078,7 @@
           <p:cNvPr id="3" name="Fußzeilenplatzhalter 2">
             <a:extLst>
               <a:ext uri="{FF2B5EF4-FFF2-40B4-BE49-F238E27FC236}">
-                <a16:creationId xmlns:a16="http://schemas.microsoft.com/office/drawing/2014/main" id="{BCA966A7-EEB5-7061-1C0E-D8900CA0EB84}"/>
+                <a16:creationId xmlns:a16="http://schemas.microsoft.com/office/drawing/2014/main" id="{F3BEE9A2-A64E-DBA1-EF63-03413D0FC9B0}"/>
               </a:ext>
             </a:extLst>
           </p:cNvPr>
@@ -2102,7 +2103,7 @@
           <p:cNvPr id="4" name="Foliennummernplatzhalter 3">
             <a:extLst>
               <a:ext uri="{FF2B5EF4-FFF2-40B4-BE49-F238E27FC236}">
-                <a16:creationId xmlns:a16="http://schemas.microsoft.com/office/drawing/2014/main" id="{D2C3C62B-D716-381C-4059-6ABF9EA2299F}"/>
+                <a16:creationId xmlns:a16="http://schemas.microsoft.com/office/drawing/2014/main" id="{66FDEFDF-0915-4A3E-B638-227B26F622C3}"/>
               </a:ext>
             </a:extLst>
           </p:cNvPr>
@@ -2118,7 +2119,7 @@
           <a:bodyPr/>
           <a:lstStyle/>
           <a:p>
-            <a:fld id="{21AE39B9-E078-4A98-B70F-66F2A2822D52}" type="slidenum">
+            <a:fld id="{D2244B1B-211B-4F22-B4EF-514648639456}" type="slidenum">
               <a:rPr lang="de-DE" smtClean="0"/>
               <a:t>‹Nr.›</a:t>
             </a:fld>
@@ -2129,7 +2130,7 @@
     </p:spTree>
     <p:extLst>
       <p:ext uri="{BB962C8B-B14F-4D97-AF65-F5344CB8AC3E}">
-        <p14:creationId xmlns:p14="http://schemas.microsoft.com/office/powerpoint/2010/main" val="1610452908"/>
+        <p14:creationId xmlns:p14="http://schemas.microsoft.com/office/powerpoint/2010/main" val="299275702"/>
       </p:ext>
     </p:extLst>
   </p:cSld>
@@ -2161,7 +2162,7 @@
           <p:cNvPr id="2" name="Titel 1">
             <a:extLst>
               <a:ext uri="{FF2B5EF4-FFF2-40B4-BE49-F238E27FC236}">
-                <a16:creationId xmlns:a16="http://schemas.microsoft.com/office/drawing/2014/main" id="{C0471FDC-B5BE-BE5F-2C62-56A3F8C53F24}"/>
+                <a16:creationId xmlns:a16="http://schemas.microsoft.com/office/drawing/2014/main" id="{E183FEDE-5EBB-D532-FCA5-3FA7F320A6B1}"/>
               </a:ext>
             </a:extLst>
           </p:cNvPr>
@@ -2198,7 +2199,7 @@
           <p:cNvPr id="3" name="Inhaltsplatzhalter 2">
             <a:extLst>
               <a:ext uri="{FF2B5EF4-FFF2-40B4-BE49-F238E27FC236}">
-                <a16:creationId xmlns:a16="http://schemas.microsoft.com/office/drawing/2014/main" id="{B1016F9B-9B4A-C28D-093F-71676F6458DC}"/>
+                <a16:creationId xmlns:a16="http://schemas.microsoft.com/office/drawing/2014/main" id="{BA314426-9BD8-7F52-AC7C-71585957A1E8}"/>
               </a:ext>
             </a:extLst>
           </p:cNvPr>
@@ -2288,7 +2289,7 @@
           <p:cNvPr id="4" name="Textplatzhalter 3">
             <a:extLst>
               <a:ext uri="{FF2B5EF4-FFF2-40B4-BE49-F238E27FC236}">
-                <a16:creationId xmlns:a16="http://schemas.microsoft.com/office/drawing/2014/main" id="{7DA40D8E-2967-24FF-3E8B-BAC7CCB33AB5}"/>
+                <a16:creationId xmlns:a16="http://schemas.microsoft.com/office/drawing/2014/main" id="{BF7A6AAC-EBC3-6CDA-CA5E-D85A304A4DB1}"/>
               </a:ext>
             </a:extLst>
           </p:cNvPr>
@@ -2359,7 +2360,7 @@
           <p:cNvPr id="5" name="Datumsplatzhalter 4">
             <a:extLst>
               <a:ext uri="{FF2B5EF4-FFF2-40B4-BE49-F238E27FC236}">
-                <a16:creationId xmlns:a16="http://schemas.microsoft.com/office/drawing/2014/main" id="{1329E82A-1952-9687-05DC-A3E64845439A}"/>
+                <a16:creationId xmlns:a16="http://schemas.microsoft.com/office/drawing/2014/main" id="{BEED20D1-BE29-4092-C48C-B3E59463A906}"/>
               </a:ext>
             </a:extLst>
           </p:cNvPr>
@@ -2375,9 +2376,9 @@
           <a:bodyPr/>
           <a:lstStyle/>
           <a:p>
-            <a:fld id="{0DF84070-F85C-4111-A372-7E705E3388D5}" type="datetimeFigureOut">
+            <a:fld id="{A8654E22-CD58-42EE-B3F1-F6E95B788638}" type="datetimeFigureOut">
               <a:rPr lang="de-DE" smtClean="0"/>
-              <a:t>08.10.2026</a:t>
+              <a:t>09.10.2026</a:t>
             </a:fld>
             <a:endParaRPr lang="de-DE"/>
           </a:p>
@@ -2388,7 +2389,7 @@
           <p:cNvPr id="6" name="Fußzeilenplatzhalter 5">
             <a:extLst>
               <a:ext uri="{FF2B5EF4-FFF2-40B4-BE49-F238E27FC236}">
-                <a16:creationId xmlns:a16="http://schemas.microsoft.com/office/drawing/2014/main" id="{B1BC66E2-643C-2C41-F61B-2BDBB4E49D3B}"/>
+                <a16:creationId xmlns:a16="http://schemas.microsoft.com/office/drawing/2014/main" id="{F6B35324-63B2-DDB1-F91F-7C6289322E09}"/>
               </a:ext>
             </a:extLst>
           </p:cNvPr>
@@ -2413,7 +2414,7 @@
           <p:cNvPr id="7" name="Foliennummernplatzhalter 6">
             <a:extLst>
               <a:ext uri="{FF2B5EF4-FFF2-40B4-BE49-F238E27FC236}">
-                <a16:creationId xmlns:a16="http://schemas.microsoft.com/office/drawing/2014/main" id="{D5BBD85F-E984-9D75-2FEA-E3A7AECFA05C}"/>
+                <a16:creationId xmlns:a16="http://schemas.microsoft.com/office/drawing/2014/main" id="{2FF49148-4755-B06B-F5B9-C95B25FA17D3}"/>
               </a:ext>
             </a:extLst>
           </p:cNvPr>
@@ -2429,7 +2430,7 @@
           <a:bodyPr/>
           <a:lstStyle/>
           <a:p>
-            <a:fld id="{21AE39B9-E078-4A98-B70F-66F2A2822D52}" type="slidenum">
+            <a:fld id="{D2244B1B-211B-4F22-B4EF-514648639456}" type="slidenum">
               <a:rPr lang="de-DE" smtClean="0"/>
               <a:t>‹Nr.›</a:t>
             </a:fld>
@@ -2440,7 +2441,7 @@
     </p:spTree>
     <p:extLst>
       <p:ext uri="{BB962C8B-B14F-4D97-AF65-F5344CB8AC3E}">
-        <p14:creationId xmlns:p14="http://schemas.microsoft.com/office/powerpoint/2010/main" val="2253104798"/>
+        <p14:creationId xmlns:p14="http://schemas.microsoft.com/office/powerpoint/2010/main" val="2346707784"/>
       </p:ext>
     </p:extLst>
   </p:cSld>
@@ -2472,7 +2473,7 @@
           <p:cNvPr id="2" name="Titel 1">
             <a:extLst>
               <a:ext uri="{FF2B5EF4-FFF2-40B4-BE49-F238E27FC236}">
-                <a16:creationId xmlns:a16="http://schemas.microsoft.com/office/drawing/2014/main" id="{A3408445-DA6D-17AA-4197-A8237B3A14D0}"/>
+                <a16:creationId xmlns:a16="http://schemas.microsoft.com/office/drawing/2014/main" id="{B03C927C-995D-EA77-764D-058D0A3AE29B}"/>
               </a:ext>
             </a:extLst>
           </p:cNvPr>
@@ -2509,7 +2510,7 @@
           <p:cNvPr id="3" name="Bildplatzhalter 2">
             <a:extLst>
               <a:ext uri="{FF2B5EF4-FFF2-40B4-BE49-F238E27FC236}">
-                <a16:creationId xmlns:a16="http://schemas.microsoft.com/office/drawing/2014/main" id="{CF358AED-361F-5A76-2782-252C2D4873A6}"/>
+                <a16:creationId xmlns:a16="http://schemas.microsoft.com/office/drawing/2014/main" id="{3DBF1F79-91F9-5CF7-59FD-91666F3CC4F3}"/>
               </a:ext>
             </a:extLst>
           </p:cNvPr>
@@ -2576,7 +2577,7 @@
           <p:cNvPr id="4" name="Textplatzhalter 3">
             <a:extLst>
               <a:ext uri="{FF2B5EF4-FFF2-40B4-BE49-F238E27FC236}">
-                <a16:creationId xmlns:a16="http://schemas.microsoft.com/office/drawing/2014/main" id="{2CF9577B-AAE0-86C8-8B96-501902F27A43}"/>
+                <a16:creationId xmlns:a16="http://schemas.microsoft.com/office/drawing/2014/main" id="{136917E7-0ED2-C591-D590-FBBC521538CB}"/>
               </a:ext>
             </a:extLst>
           </p:cNvPr>
@@ -2647,7 +2648,7 @@
           <p:cNvPr id="5" name="Datumsplatzhalter 4">
             <a:extLst>
               <a:ext uri="{FF2B5EF4-FFF2-40B4-BE49-F238E27FC236}">
-                <a16:creationId xmlns:a16="http://schemas.microsoft.com/office/drawing/2014/main" id="{068F2BFC-5F6E-63FB-2D4E-F038A3FDE434}"/>
+                <a16:creationId xmlns:a16="http://schemas.microsoft.com/office/drawing/2014/main" id="{43ADAD82-3643-F0FD-7575-353F1037D142}"/>
               </a:ext>
             </a:extLst>
           </p:cNvPr>
@@ -2663,9 +2664,9 @@
           <a:bodyPr/>
           <a:lstStyle/>
           <a:p>
-            <a:fld id="{0DF84070-F85C-4111-A372-7E705E3388D5}" type="datetimeFigureOut">
+            <a:fld id="{A8654E22-CD58-42EE-B3F1-F6E95B788638}" type="datetimeFigureOut">
               <a:rPr lang="de-DE" smtClean="0"/>
-              <a:t>08.10.2026</a:t>
+              <a:t>09.10.2026</a:t>
             </a:fld>
             <a:endParaRPr lang="de-DE"/>
           </a:p>
@@ -2676,7 +2677,7 @@
           <p:cNvPr id="6" name="Fußzeilenplatzhalter 5">
             <a:extLst>
               <a:ext uri="{FF2B5EF4-FFF2-40B4-BE49-F238E27FC236}">
-                <a16:creationId xmlns:a16="http://schemas.microsoft.com/office/drawing/2014/main" id="{4D194796-F8F0-111B-CD42-6FBAB4A8F582}"/>
+                <a16:creationId xmlns:a16="http://schemas.microsoft.com/office/drawing/2014/main" id="{2BDBE84D-6471-1B67-A42C-5AE77A6DF155}"/>
               </a:ext>
             </a:extLst>
           </p:cNvPr>
@@ -2701,7 +2702,7 @@
           <p:cNvPr id="7" name="Foliennummernplatzhalter 6">
             <a:extLst>
               <a:ext uri="{FF2B5EF4-FFF2-40B4-BE49-F238E27FC236}">
-                <a16:creationId xmlns:a16="http://schemas.microsoft.com/office/drawing/2014/main" id="{443CAE56-87EB-B708-3298-AF53F4195C63}"/>
+                <a16:creationId xmlns:a16="http://schemas.microsoft.com/office/drawing/2014/main" id="{082B67A0-3C80-8BA2-3BD6-F14E05761699}"/>
               </a:ext>
             </a:extLst>
           </p:cNvPr>
@@ -2717,7 +2718,7 @@
           <a:bodyPr/>
           <a:lstStyle/>
           <a:p>
-            <a:fld id="{21AE39B9-E078-4A98-B70F-66F2A2822D52}" type="slidenum">
+            <a:fld id="{D2244B1B-211B-4F22-B4EF-514648639456}" type="slidenum">
               <a:rPr lang="de-DE" smtClean="0"/>
               <a:t>‹Nr.›</a:t>
             </a:fld>
@@ -2728,7 +2729,7 @@
     </p:spTree>
     <p:extLst>
       <p:ext uri="{BB962C8B-B14F-4D97-AF65-F5344CB8AC3E}">
-        <p14:creationId xmlns:p14="http://schemas.microsoft.com/office/powerpoint/2010/main" val="2249777436"/>
+        <p14:creationId xmlns:p14="http://schemas.microsoft.com/office/powerpoint/2010/main" val="3215409580"/>
       </p:ext>
     </p:extLst>
   </p:cSld>
@@ -2765,7 +2766,7 @@
           <p:cNvPr id="2" name="Titelplatzhalter 1">
             <a:extLst>
               <a:ext uri="{FF2B5EF4-FFF2-40B4-BE49-F238E27FC236}">
-                <a16:creationId xmlns:a16="http://schemas.microsoft.com/office/drawing/2014/main" id="{6961FCF9-6E39-72C8-DC43-10F8F7F96DE5}"/>
+                <a16:creationId xmlns:a16="http://schemas.microsoft.com/office/drawing/2014/main" id="{E72CDBCF-A99D-52A9-6F34-B6D597A79846}"/>
               </a:ext>
             </a:extLst>
           </p:cNvPr>
@@ -2803,7 +2804,7 @@
           <p:cNvPr id="3" name="Textplatzhalter 2">
             <a:extLst>
               <a:ext uri="{FF2B5EF4-FFF2-40B4-BE49-F238E27FC236}">
-                <a16:creationId xmlns:a16="http://schemas.microsoft.com/office/drawing/2014/main" id="{B6F847F4-99EF-091B-51AA-AADEBC306D08}"/>
+                <a16:creationId xmlns:a16="http://schemas.microsoft.com/office/drawing/2014/main" id="{0352075A-285E-9951-D96E-91B24FFC3714}"/>
               </a:ext>
             </a:extLst>
           </p:cNvPr>
@@ -2870,7 +2871,7 @@
           <p:cNvPr id="4" name="Datumsplatzhalter 3">
             <a:extLst>
               <a:ext uri="{FF2B5EF4-FFF2-40B4-BE49-F238E27FC236}">
-                <a16:creationId xmlns:a16="http://schemas.microsoft.com/office/drawing/2014/main" id="{E824E3B4-483D-9BD4-1E34-DE76F6BAC417}"/>
+                <a16:creationId xmlns:a16="http://schemas.microsoft.com/office/drawing/2014/main" id="{C362A46C-5A2C-8715-BBC8-29E78FC9BC4C}"/>
               </a:ext>
             </a:extLst>
           </p:cNvPr>
@@ -2904,9 +2905,9 @@
             </a:lvl1pPr>
           </a:lstStyle>
           <a:p>
-            <a:fld id="{0DF84070-F85C-4111-A372-7E705E3388D5}" type="datetimeFigureOut">
+            <a:fld id="{A8654E22-CD58-42EE-B3F1-F6E95B788638}" type="datetimeFigureOut">
               <a:rPr lang="de-DE" smtClean="0"/>
-              <a:t>08.10.2026</a:t>
+              <a:t>09.10.2026</a:t>
             </a:fld>
             <a:endParaRPr lang="de-DE"/>
           </a:p>
@@ -2917,7 +2918,7 @@
           <p:cNvPr id="5" name="Fußzeilenplatzhalter 4">
             <a:extLst>
               <a:ext uri="{FF2B5EF4-FFF2-40B4-BE49-F238E27FC236}">
-                <a16:creationId xmlns:a16="http://schemas.microsoft.com/office/drawing/2014/main" id="{3EC7511D-8986-E26B-2F59-3BBB0A3CFC5B}"/>
+                <a16:creationId xmlns:a16="http://schemas.microsoft.com/office/drawing/2014/main" id="{05D74AC5-3817-4760-FAF0-74A88FAC9842}"/>
               </a:ext>
             </a:extLst>
           </p:cNvPr>
@@ -2960,7 +2961,7 @@
           <p:cNvPr id="6" name="Foliennummernplatzhalter 5">
             <a:extLst>
               <a:ext uri="{FF2B5EF4-FFF2-40B4-BE49-F238E27FC236}">
-                <a16:creationId xmlns:a16="http://schemas.microsoft.com/office/drawing/2014/main" id="{8C796DA1-3F43-4C33-23BB-0A6697E7124E}"/>
+                <a16:creationId xmlns:a16="http://schemas.microsoft.com/office/drawing/2014/main" id="{89BF0D3F-5C6E-584F-0D16-9EAFADB1E77B}"/>
               </a:ext>
             </a:extLst>
           </p:cNvPr>
@@ -2994,7 +2995,7 @@
             </a:lvl1pPr>
           </a:lstStyle>
           <a:p>
-            <a:fld id="{21AE39B9-E078-4A98-B70F-66F2A2822D52}" type="slidenum">
+            <a:fld id="{D2244B1B-211B-4F22-B4EF-514648639456}" type="slidenum">
               <a:rPr lang="de-DE" smtClean="0"/>
               <a:t>‹Nr.›</a:t>
             </a:fld>
@@ -3005,7 +3006,7 @@
     </p:spTree>
     <p:extLst>
       <p:ext uri="{BB962C8B-B14F-4D97-AF65-F5344CB8AC3E}">
-        <p14:creationId xmlns:p14="http://schemas.microsoft.com/office/powerpoint/2010/main" val="4024119320"/>
+        <p14:creationId xmlns:p14="http://schemas.microsoft.com/office/powerpoint/2010/main" val="3113489965"/>
       </p:ext>
     </p:extLst>
   </p:cSld>
@@ -3328,7 +3329,7 @@
           <p:cNvPr id="2" name="Titel 1">
             <a:extLst>
               <a:ext uri="{FF2B5EF4-FFF2-40B4-BE49-F238E27FC236}">
-                <a16:creationId xmlns:a16="http://schemas.microsoft.com/office/drawing/2014/main" id="{25D085FB-B4D3-27B3-4626-93965D8F25E9}"/>
+                <a16:creationId xmlns:a16="http://schemas.microsoft.com/office/drawing/2014/main" id="{AF06850E-E9E3-0CFD-25F4-713453AFC883}"/>
               </a:ext>
             </a:extLst>
           </p:cNvPr>
@@ -3356,7 +3357,7 @@
           <p:cNvPr id="4" name="Grafik 3">
             <a:extLst>
               <a:ext uri="{FF2B5EF4-FFF2-40B4-BE49-F238E27FC236}">
-                <a16:creationId xmlns:a16="http://schemas.microsoft.com/office/drawing/2014/main" id="{D106B2B3-1CAB-507B-8F87-BEA001DB8B0A}"/>
+                <a16:creationId xmlns:a16="http://schemas.microsoft.com/office/drawing/2014/main" id="{8A181F27-8141-7963-E9A7-91DE5C070604}"/>
               </a:ext>
             </a:extLst>
           </p:cNvPr>
@@ -3386,7 +3387,7 @@
           <p:cNvPr id="6" name="Grafik 5">
             <a:extLst>
               <a:ext uri="{FF2B5EF4-FFF2-40B4-BE49-F238E27FC236}">
-                <a16:creationId xmlns:a16="http://schemas.microsoft.com/office/drawing/2014/main" id="{9FEC339E-90CB-98F6-F008-5D14CD0BFE6F}"/>
+                <a16:creationId xmlns:a16="http://schemas.microsoft.com/office/drawing/2014/main" id="{021E1F1A-C949-0EDC-7B4A-193BBF679472}"/>
               </a:ext>
             </a:extLst>
           </p:cNvPr>
@@ -3416,7 +3417,7 @@
           <p:cNvPr id="8" name="Grafik 7">
             <a:extLst>
               <a:ext uri="{FF2B5EF4-FFF2-40B4-BE49-F238E27FC236}">
-                <a16:creationId xmlns:a16="http://schemas.microsoft.com/office/drawing/2014/main" id="{28702830-F027-B091-7715-994BA003011F}"/>
+                <a16:creationId xmlns:a16="http://schemas.microsoft.com/office/drawing/2014/main" id="{17EFB27C-8691-9874-AE20-631F143A3C9D}"/>
               </a:ext>
             </a:extLst>
           </p:cNvPr>
@@ -3446,7 +3447,7 @@
           <p:cNvPr id="10" name="Grafik 9">
             <a:extLst>
               <a:ext uri="{FF2B5EF4-FFF2-40B4-BE49-F238E27FC236}">
-                <a16:creationId xmlns:a16="http://schemas.microsoft.com/office/drawing/2014/main" id="{87A56B33-7159-1415-D662-88C145231CEE}"/>
+                <a16:creationId xmlns:a16="http://schemas.microsoft.com/office/drawing/2014/main" id="{C0A9A7DC-D9F3-4590-2474-2FF3D7EF8D93}"/>
               </a:ext>
             </a:extLst>
           </p:cNvPr>
@@ -3476,7 +3477,7 @@
           <p:cNvPr id="12" name="Grafik 11">
             <a:extLst>
               <a:ext uri="{FF2B5EF4-FFF2-40B4-BE49-F238E27FC236}">
-                <a16:creationId xmlns:a16="http://schemas.microsoft.com/office/drawing/2014/main" id="{568B6393-6DFE-9271-D586-E7D0B3C683EA}"/>
+                <a16:creationId xmlns:a16="http://schemas.microsoft.com/office/drawing/2014/main" id="{035F1746-160C-6F42-C52F-91975DD92412}"/>
               </a:ext>
             </a:extLst>
           </p:cNvPr>
@@ -3506,7 +3507,7 @@
           <p:cNvPr id="14" name="Grafik 13">
             <a:extLst>
               <a:ext uri="{FF2B5EF4-FFF2-40B4-BE49-F238E27FC236}">
-                <a16:creationId xmlns:a16="http://schemas.microsoft.com/office/drawing/2014/main" id="{27379C20-240E-C4C9-46B9-2F93D27D89C1}"/>
+                <a16:creationId xmlns:a16="http://schemas.microsoft.com/office/drawing/2014/main" id="{16F0E24F-DCE5-4C39-24DD-48B344D6A6AB}"/>
               </a:ext>
             </a:extLst>
           </p:cNvPr>
@@ -3534,7 +3535,7 @@
     </p:spTree>
     <p:extLst>
       <p:ext uri="{BB962C8B-B14F-4D97-AF65-F5344CB8AC3E}">
-        <p14:creationId xmlns:p14="http://schemas.microsoft.com/office/powerpoint/2010/main" val="2246816488"/>
+        <p14:creationId xmlns:p14="http://schemas.microsoft.com/office/powerpoint/2010/main" val="29323533"/>
       </p:ext>
     </p:extLst>
   </p:cSld>
@@ -3566,7 +3567,7 @@
           <p:cNvPr id="2" name="Titel 1">
             <a:extLst>
               <a:ext uri="{FF2B5EF4-FFF2-40B4-BE49-F238E27FC236}">
-                <a16:creationId xmlns:a16="http://schemas.microsoft.com/office/drawing/2014/main" id="{06B88C13-983C-D74D-BC90-E1C2B94A1A82}"/>
+                <a16:creationId xmlns:a16="http://schemas.microsoft.com/office/drawing/2014/main" id="{CD7C1E22-F42A-5F97-D504-768ADF421382}"/>
               </a:ext>
             </a:extLst>
           </p:cNvPr>
@@ -3594,7 +3595,7 @@
           <p:cNvPr id="4" name="Grafik 3">
             <a:extLst>
               <a:ext uri="{FF2B5EF4-FFF2-40B4-BE49-F238E27FC236}">
-                <a16:creationId xmlns:a16="http://schemas.microsoft.com/office/drawing/2014/main" id="{AC8A3CE0-3508-5384-7D79-D95679D16EA6}"/>
+                <a16:creationId xmlns:a16="http://schemas.microsoft.com/office/drawing/2014/main" id="{13528C07-60F4-B759-814D-7FE40A673195}"/>
               </a:ext>
             </a:extLst>
           </p:cNvPr>
@@ -3624,7 +3625,7 @@
           <p:cNvPr id="6" name="Grafik 5">
             <a:extLst>
               <a:ext uri="{FF2B5EF4-FFF2-40B4-BE49-F238E27FC236}">
-                <a16:creationId xmlns:a16="http://schemas.microsoft.com/office/drawing/2014/main" id="{A1836A6D-B395-B49A-28C2-5B6C1917A215}"/>
+                <a16:creationId xmlns:a16="http://schemas.microsoft.com/office/drawing/2014/main" id="{BB707545-A7D4-8FE5-E2D0-76567B3F3BDB}"/>
               </a:ext>
             </a:extLst>
           </p:cNvPr>
@@ -3654,7 +3655,7 @@
           <p:cNvPr id="8" name="Grafik 7">
             <a:extLst>
               <a:ext uri="{FF2B5EF4-FFF2-40B4-BE49-F238E27FC236}">
-                <a16:creationId xmlns:a16="http://schemas.microsoft.com/office/drawing/2014/main" id="{B9DD0D7E-1D15-8379-FE4F-1D71DC766A3F}"/>
+                <a16:creationId xmlns:a16="http://schemas.microsoft.com/office/drawing/2014/main" id="{B111DC62-9E4A-2461-8014-3608692158C9}"/>
               </a:ext>
             </a:extLst>
           </p:cNvPr>
@@ -3684,7 +3685,7 @@
           <p:cNvPr id="10" name="Grafik 9">
             <a:extLst>
               <a:ext uri="{FF2B5EF4-FFF2-40B4-BE49-F238E27FC236}">
-                <a16:creationId xmlns:a16="http://schemas.microsoft.com/office/drawing/2014/main" id="{239BB0D1-0ACD-19C5-41CA-9F05227CB419}"/>
+                <a16:creationId xmlns:a16="http://schemas.microsoft.com/office/drawing/2014/main" id="{1FA4D61B-5BCE-21D0-048C-386F077BE68E}"/>
               </a:ext>
             </a:extLst>
           </p:cNvPr>
@@ -3714,7 +3715,7 @@
           <p:cNvPr id="12" name="Grafik 11">
             <a:extLst>
               <a:ext uri="{FF2B5EF4-FFF2-40B4-BE49-F238E27FC236}">
-                <a16:creationId xmlns:a16="http://schemas.microsoft.com/office/drawing/2014/main" id="{E7542B56-82F9-BFE7-3EEA-9AE4B271075F}"/>
+                <a16:creationId xmlns:a16="http://schemas.microsoft.com/office/drawing/2014/main" id="{B5DD46C5-6487-D8DA-E321-55DBE1C8D86C}"/>
               </a:ext>
             </a:extLst>
           </p:cNvPr>
@@ -3744,7 +3745,7 @@
           <p:cNvPr id="14" name="Grafik 13">
             <a:extLst>
               <a:ext uri="{FF2B5EF4-FFF2-40B4-BE49-F238E27FC236}">
-                <a16:creationId xmlns:a16="http://schemas.microsoft.com/office/drawing/2014/main" id="{DC0D4518-EB30-E6BF-226B-30F1EDBCD97C}"/>
+                <a16:creationId xmlns:a16="http://schemas.microsoft.com/office/drawing/2014/main" id="{6183D9B6-2831-4E20-7035-74D751A3D08F}"/>
               </a:ext>
             </a:extLst>
           </p:cNvPr>
@@ -3772,7 +3773,7 @@
     </p:spTree>
     <p:extLst>
       <p:ext uri="{BB962C8B-B14F-4D97-AF65-F5344CB8AC3E}">
-        <p14:creationId xmlns:p14="http://schemas.microsoft.com/office/powerpoint/2010/main" val="2561254773"/>
+        <p14:creationId xmlns:p14="http://schemas.microsoft.com/office/powerpoint/2010/main" val="695712574"/>
       </p:ext>
     </p:extLst>
   </p:cSld>
@@ -3804,7 +3805,7 @@
           <p:cNvPr id="2" name="Titel 1">
             <a:extLst>
               <a:ext uri="{FF2B5EF4-FFF2-40B4-BE49-F238E27FC236}">
-                <a16:creationId xmlns:a16="http://schemas.microsoft.com/office/drawing/2014/main" id="{16C3CFA4-F6D1-E022-A921-8A76DCDD609C}"/>
+                <a16:creationId xmlns:a16="http://schemas.microsoft.com/office/drawing/2014/main" id="{C225249E-7384-3455-DCFA-B812FA5E735B}"/>
               </a:ext>
             </a:extLst>
           </p:cNvPr>
@@ -3833,7 +3834,7 @@
           <p:cNvPr id="4" name="Grafik 3">
             <a:extLst>
               <a:ext uri="{FF2B5EF4-FFF2-40B4-BE49-F238E27FC236}">
-                <a16:creationId xmlns:a16="http://schemas.microsoft.com/office/drawing/2014/main" id="{B8616272-4879-8B5F-95C8-20080F927CC1}"/>
+                <a16:creationId xmlns:a16="http://schemas.microsoft.com/office/drawing/2014/main" id="{A32D3322-673B-D059-CAA5-92495FE924B2}"/>
               </a:ext>
             </a:extLst>
           </p:cNvPr>
@@ -3863,7 +3864,7 @@
           <p:cNvPr id="6" name="Grafik 5">
             <a:extLst>
               <a:ext uri="{FF2B5EF4-FFF2-40B4-BE49-F238E27FC236}">
-                <a16:creationId xmlns:a16="http://schemas.microsoft.com/office/drawing/2014/main" id="{E847E740-5732-8ECD-ABD0-8ED235E44559}"/>
+                <a16:creationId xmlns:a16="http://schemas.microsoft.com/office/drawing/2014/main" id="{5034239E-6D45-DC67-4C9A-4B678B5F40F0}"/>
               </a:ext>
             </a:extLst>
           </p:cNvPr>
@@ -3891,7 +3892,95 @@
     </p:spTree>
     <p:extLst>
       <p:ext uri="{BB962C8B-B14F-4D97-AF65-F5344CB8AC3E}">
-        <p14:creationId xmlns:p14="http://schemas.microsoft.com/office/powerpoint/2010/main" val="1566821417"/>
+        <p14:creationId xmlns:p14="http://schemas.microsoft.com/office/powerpoint/2010/main" val="4077660794"/>
+      </p:ext>
+    </p:extLst>
+  </p:cSld>
+  <p:clrMapOvr>
+    <a:masterClrMapping/>
+  </p:clrMapOvr>
+</p:sld>
+</file>
+
+<file path=ppt/slides/slide4.xml><?xml version="1.0" encoding="utf-8"?>
+<p:sld xmlns:a="http://schemas.openxmlformats.org/drawingml/2006/main" xmlns:r="http://schemas.openxmlformats.org/officeDocument/2006/relationships" xmlns:p="http://schemas.openxmlformats.org/presentationml/2006/main">
+  <p:cSld>
+    <p:spTree>
+      <p:nvGrpSpPr>
+        <p:cNvPr id="1" name=""/>
+        <p:cNvGrpSpPr/>
+        <p:nvPr/>
+      </p:nvGrpSpPr>
+      <p:grpSpPr>
+        <a:xfrm>
+          <a:off x="0" y="0"/>
+          <a:ext cx="0" cy="0"/>
+          <a:chOff x="0" y="0"/>
+          <a:chExt cx="0" cy="0"/>
+        </a:xfrm>
+      </p:grpSpPr>
+      <p:sp>
+        <p:nvSpPr>
+          <p:cNvPr id="2" name="Titel 1">
+            <a:extLst>
+              <a:ext uri="{FF2B5EF4-FFF2-40B4-BE49-F238E27FC236}">
+                <a16:creationId xmlns:a16="http://schemas.microsoft.com/office/drawing/2014/main" id="{EB2B3253-88CB-5CC4-5FF2-262FA421E6A9}"/>
+              </a:ext>
+            </a:extLst>
+          </p:cNvPr>
+          <p:cNvSpPr>
+            <a:spLocks noGrp="1"/>
+          </p:cNvSpPr>
+          <p:nvPr>
+            <p:ph type="title"/>
+          </p:nvPr>
+        </p:nvSpPr>
+        <p:spPr/>
+        <p:txBody>
+          <a:bodyPr/>
+          <a:lstStyle/>
+          <a:p>
+            <a:r>
+              <a:rPr lang="de-DE"/>
+              <a:t>GDI records: PolyDraw, MaskBlt, PlgBlt</a:t>
+            </a:r>
+          </a:p>
+        </p:txBody>
+      </p:sp>
+      <p:pic>
+        <p:nvPicPr>
+          <p:cNvPr id="4" name="Grafik 3">
+            <a:extLst>
+              <a:ext uri="{FF2B5EF4-FFF2-40B4-BE49-F238E27FC236}">
+                <a16:creationId xmlns:a16="http://schemas.microsoft.com/office/drawing/2014/main" id="{4F0897F9-FA40-111F-E74F-BACBD1E88264}"/>
+              </a:ext>
+            </a:extLst>
+          </p:cNvPr>
+          <p:cNvPicPr>
+            <a:picLocks/>
+          </p:cNvPicPr>
+          <p:nvPr/>
+        </p:nvPicPr>
+        <p:blipFill>
+          <a:blip r:embed="rId2"/>
+          <a:stretch>
+            <a:fillRect/>
+          </a:stretch>
+        </p:blipFill>
+        <p:spPr>
+          <a:xfrm>
+            <a:off x="508000" y="1651000"/>
+            <a:ext cx="7620000" cy="3810000"/>
+          </a:xfrm>
+          <a:prstGeom prst="rect">
+            <a:avLst/>
+          </a:prstGeom>
+        </p:spPr>
+      </p:pic>
+    </p:spTree>
+    <p:extLst>
+      <p:ext uri="{BB962C8B-B14F-4D97-AF65-F5344CB8AC3E}">
+        <p14:creationId xmlns:p14="http://schemas.microsoft.com/office/powerpoint/2010/main" val="1178493563"/>
       </p:ext>
     </p:extLst>
   </p:cSld>

</xml_diff>